<commit_message>
Embed click-to-play demo video in the executive deck
Add a rendered MP4 of the RAG-vs-NSAI walkthrough and embed it as a new
slide 4 in the exec summary so the demo plays inside the slide on click
(offline, no add-ins). Also commit the standalone MP4 for reuse.

https://claude.ai/code/session_01Njv3bBvPktKkkSQNzyxEeu
</commit_message>
<xml_diff>
--- a/NSAI-Small-Commercial-Exec-Summary.pptx
+++ b/NSAI-Small-Commercial-Exec-Summary.pptx
@@ -8,6 +8,7 @@
     <p:sldId id="256" r:id="rId7"/>
     <p:sldId id="257" r:id="rId8"/>
     <p:sldId id="258" r:id="rId9"/>
+    <p:sldId id="262" r:id="rId13"/>
     <p:sldId id="259" r:id="rId10"/>
     <p:sldId id="260" r:id="rId11"/>
     <p:sldId id="261" r:id="rId12"/>
@@ -7483,6 +7484,192 @@
   <p:clrMapOvr>
     <a:masterClrMapping/>
   </p:clrMapOvr>
+</p:sld>
+</file>
+
+<file path=ppt/slides/slide7.xml><?xml version="1.0" encoding="utf-8"?>
+<p:sld xmlns:a="http://schemas.openxmlformats.org/drawingml/2006/main" xmlns:p="http://schemas.openxmlformats.org/presentationml/2006/main" xmlns:r="http://schemas.openxmlformats.org/officeDocument/2006/relationships">
+  <p:cSld>
+    <p:bg>
+      <p:bgPr>
+        <a:solidFill>
+          <a:srgbClr val="0F1419"/>
+        </a:solidFill>
+        <a:effectLst/>
+      </p:bgPr>
+    </p:bg>
+    <p:spTree>
+      <p:nvGrpSpPr>
+        <p:cNvPr id="1" name=""/>
+        <p:cNvGrpSpPr/>
+        <p:nvPr/>
+      </p:nvGrpSpPr>
+      <p:grpSpPr/>
+      <p:sp>
+        <p:nvSpPr>
+          <p:cNvPr id="2" name="TextBox 1"/>
+          <p:cNvSpPr txBox="1"/>
+          <p:nvPr/>
+        </p:nvSpPr>
+        <p:spPr>
+          <a:xfrm>
+            <a:off x="822960" y="384048"/>
+            <a:ext cx="10515600" cy="274320"/>
+          </a:xfrm>
+          <a:prstGeom prst="rect">
+            <a:avLst/>
+          </a:prstGeom>
+          <a:noFill/>
+        </p:spPr>
+        <p:txBody>
+          <a:bodyPr wrap="square" lIns="0" rIns="0" tIns="0" bIns="0">
+            <a:spAutoFit/>
+          </a:bodyPr>
+          <a:lstStyle/>
+          <a:p>
+            <a:pPr algn="l"/>
+            <a:r>
+              <a:rPr sz="1100" b="1" i="0">
+                <a:solidFill>
+                  <a:srgbClr val="C8A951"/>
+                </a:solidFill>
+                <a:latin typeface="Calibri"/>
+              </a:rPr>
+              <a:t>THE LIVE WALKTHROUGH  ·  EMBEDDED VIDEO — CLICK TO PLAY IN-SLIDE</a:t>
+            </a:r>
+          </a:p>
+        </p:txBody>
+      </p:sp>
+      <p:sp>
+        <p:nvSpPr>
+          <p:cNvPr id="3" name="TextBox 2"/>
+          <p:cNvSpPr txBox="1"/>
+          <p:nvPr/>
+        </p:nvSpPr>
+        <p:spPr>
+          <a:xfrm>
+            <a:off x="822960" y="713232"/>
+            <a:ext cx="10515600" cy="548640"/>
+          </a:xfrm>
+          <a:prstGeom prst="rect">
+            <a:avLst/>
+          </a:prstGeom>
+          <a:noFill/>
+        </p:spPr>
+        <p:txBody>
+          <a:bodyPr wrap="square" lIns="0" rIns="0" tIns="0" bIns="0">
+            <a:spAutoFit/>
+          </a:bodyPr>
+          <a:lstStyle/>
+          <a:p>
+            <a:pPr algn="l"/>
+            <a:r>
+              <a:rPr sz="2400" b="0" i="0">
+                <a:solidFill>
+                  <a:srgbClr val="F4EFE6"/>
+                </a:solidFill>
+                <a:latin typeface="Georgia"/>
+              </a:rPr>
+              <a:t>Watch both models run on the same submission.</a:t>
+            </a:r>
+          </a:p>
+        </p:txBody>
+      </p:sp>
+      <p:pic>
+        <p:nvPicPr>
+          <p:cNvPr id="4" name="NSAI-demo-run.mp4">
+            <a:hlinkClick r:id="" action="ppaction://media"/>
+          </p:cNvPr>
+          <p:cNvPicPr>
+            <a:picLocks noChangeAspect="1"/>
+          </p:cNvPicPr>
+          <p:nvPr>
+            <a:videoFile r:link="rId3"/>
+            <p:extLst>
+              <p:ext uri="{DAA4B4D4-6D71-4841-9C94-3DE7FCFB9230}">
+                <p14:media xmlns:p14="http://schemas.microsoft.com/office/powerpoint/2010/main" r:embed="rId2"/>
+              </p:ext>
+            </p:extLst>
+          </p:nvPr>
+        </p:nvPicPr>
+        <p:blipFill>
+          <a:blip r:embed="rId4"/>
+          <a:stretch>
+            <a:fillRect/>
+          </a:stretch>
+        </p:blipFill>
+        <p:spPr>
+          <a:xfrm>
+            <a:off x="1475721" y="1371600"/>
+            <a:ext cx="9240252" cy="5212080"/>
+          </a:xfrm>
+          <a:prstGeom prst="rect">
+            <a:avLst/>
+          </a:prstGeom>
+        </p:spPr>
+      </p:pic>
+      <p:sp>
+        <p:nvSpPr>
+          <p:cNvPr id="5" name="TextBox 4"/>
+          <p:cNvSpPr txBox="1"/>
+          <p:nvPr/>
+        </p:nvSpPr>
+        <p:spPr>
+          <a:xfrm>
+            <a:off x="822960" y="6510528"/>
+            <a:ext cx="10515600" cy="274320"/>
+          </a:xfrm>
+          <a:prstGeom prst="rect">
+            <a:avLst/>
+          </a:prstGeom>
+          <a:noFill/>
+        </p:spPr>
+        <p:txBody>
+          <a:bodyPr wrap="square" lIns="0" rIns="0" tIns="0" bIns="0">
+            <a:spAutoFit/>
+          </a:bodyPr>
+          <a:lstStyle/>
+          <a:p>
+            <a:pPr algn="l"/>
+            <a:r>
+              <a:rPr sz="1000" b="0" i="1">
+                <a:solidFill>
+                  <a:srgbClr val="6B6458"/>
+                </a:solidFill>
+                <a:latin typeface="Calibri"/>
+              </a:rPr>
+              <a:t>Plays inside the slide on click (no internet needed). 13-second run · loops back to the start when finished.</a:t>
+            </a:r>
+          </a:p>
+        </p:txBody>
+      </p:sp>
+    </p:spTree>
+  </p:cSld>
+  <p:clrMapOvr>
+    <a:masterClrMapping/>
+  </p:clrMapOvr>
+  <p:timing>
+    <p:tnLst>
+      <p:par>
+        <p:cTn id="1" dur="indefinite" restart="never" nodeType="tmRoot">
+          <p:childTnLst>
+            <p:video>
+              <p:cMediaNode vol="80000">
+                <p:cTn id="2" fill="hold" display="0">
+                  <p:stCondLst>
+                    <p:cond delay="indefinite"/>
+                  </p:stCondLst>
+                </p:cTn>
+                <p:tgtEl>
+                  <p:spTgt spid="4"/>
+                </p:tgtEl>
+              </p:cMediaNode>
+            </p:video>
+          </p:childTnLst>
+        </p:cTn>
+      </p:par>
+    </p:tnLst>
+  </p:timing>
 </p:sld>
 </file>
 

</xml_diff>

<commit_message>
Combine embedded video and Web Viewer option on one demo slide
Slide 4 now presents both ways to show the live demo: the offline
click-to-play video on the left, and a Web Viewer drop zone on the
right with the published URL, insert steps, a working hyperlink, and
presenter notes — so the choice can be made after the site goes live.

https://claude.ai/code/session_01Njv3bBvPktKkkSQNzyxEeu
</commit_message>
<xml_diff>
--- a/NSAI-Small-Commercial-Exec-Summary.pptx
+++ b/NSAI-Small-Commercial-Exec-Summary.pptx
@@ -111,6 +111,451 @@
     </a:lvl9pPr>
   </p:defaultTextStyle>
 </p:presentation>
+</file>
+
+<file path=ppt/notesMasters/notesMaster1.xml><?xml version="1.0" encoding="utf-8"?>
+<p:notesMaster xmlns:a="http://schemas.openxmlformats.org/drawingml/2006/main" xmlns:p="http://schemas.openxmlformats.org/presentationml/2006/main" xmlns:r="http://schemas.openxmlformats.org/officeDocument/2006/relationships">
+  <p:cSld>
+    <p:bg>
+      <p:bgRef idx="1001">
+        <a:schemeClr val="bg1"/>
+      </p:bgRef>
+    </p:bg>
+    <p:spTree>
+      <p:nvGrpSpPr>
+        <p:cNvPr id="1" name=""/>
+        <p:cNvGrpSpPr/>
+        <p:nvPr/>
+      </p:nvGrpSpPr>
+      <p:grpSpPr>
+        <a:xfrm>
+          <a:off x="0" y="0"/>
+          <a:ext cx="0" cy="0"/>
+          <a:chOff x="0" y="0"/>
+          <a:chExt cx="0" cy="0"/>
+        </a:xfrm>
+      </p:grpSpPr>
+      <p:sp>
+        <p:nvSpPr>
+          <p:cNvPr id="2" name="Header Placeholder 1"/>
+          <p:cNvSpPr>
+            <a:spLocks noGrp="1"/>
+          </p:cNvSpPr>
+          <p:nvPr>
+            <p:ph type="hdr" sz="quarter"/>
+          </p:nvPr>
+        </p:nvSpPr>
+        <p:spPr>
+          <a:xfrm>
+            <a:off x="0" y="0"/>
+            <a:ext cx="2971800" cy="457200"/>
+          </a:xfrm>
+          <a:prstGeom prst="rect">
+            <a:avLst/>
+          </a:prstGeom>
+        </p:spPr>
+        <p:txBody>
+          <a:bodyPr vert="horz" lIns="91440" tIns="45720" rIns="91440" bIns="45720" rtlCol="0"/>
+          <a:lstStyle>
+            <a:lvl1pPr algn="l">
+              <a:defRPr sz="1200"/>
+            </a:lvl1pPr>
+          </a:lstStyle>
+          <a:p>
+            <a:endParaRPr lang="en-US"/>
+          </a:p>
+        </p:txBody>
+      </p:sp>
+      <p:sp>
+        <p:nvSpPr>
+          <p:cNvPr id="3" name="Date Placeholder 2"/>
+          <p:cNvSpPr>
+            <a:spLocks noGrp="1"/>
+          </p:cNvSpPr>
+          <p:nvPr>
+            <p:ph type="dt" idx="1"/>
+          </p:nvPr>
+        </p:nvSpPr>
+        <p:spPr>
+          <a:xfrm>
+            <a:off x="3884613" y="0"/>
+            <a:ext cx="2971800" cy="457200"/>
+          </a:xfrm>
+          <a:prstGeom prst="rect">
+            <a:avLst/>
+          </a:prstGeom>
+        </p:spPr>
+        <p:txBody>
+          <a:bodyPr vert="horz" lIns="91440" tIns="45720" rIns="91440" bIns="45720" rtlCol="0"/>
+          <a:lstStyle>
+            <a:lvl1pPr algn="r">
+              <a:defRPr sz="1200"/>
+            </a:lvl1pPr>
+          </a:lstStyle>
+          <a:p>
+            <a:fld id="{0F89C1C7-3DCD-1040-A9CF-14679D8B5DDD}" type="datetimeFigureOut">
+              <a:rPr lang="en-US" smtClean="0"/>
+              <a:t>10/17/16</a:t>
+            </a:fld>
+            <a:endParaRPr lang="en-US"/>
+          </a:p>
+        </p:txBody>
+      </p:sp>
+      <p:sp>
+        <p:nvSpPr>
+          <p:cNvPr id="4" name="Slide Image Placeholder 3"/>
+          <p:cNvSpPr>
+            <a:spLocks noGrp="1" noRot="1" noChangeAspect="1"/>
+          </p:cNvSpPr>
+          <p:nvPr>
+            <p:ph type="sldImg" idx="2"/>
+          </p:nvPr>
+        </p:nvSpPr>
+        <p:spPr>
+          <a:xfrm>
+            <a:off x="1143000" y="685800"/>
+            <a:ext cx="4572000" cy="3429000"/>
+          </a:xfrm>
+          <a:prstGeom prst="rect">
+            <a:avLst/>
+          </a:prstGeom>
+          <a:noFill/>
+          <a:ln w="12700">
+            <a:solidFill>
+              <a:prstClr val="black"/>
+            </a:solidFill>
+          </a:ln>
+        </p:spPr>
+        <p:txBody>
+          <a:bodyPr vert="horz" lIns="91440" tIns="45720" rIns="91440" bIns="45720" rtlCol="0" anchor="ctr"/>
+          <a:lstStyle/>
+          <a:p>
+            <a:endParaRPr lang="en-US"/>
+          </a:p>
+        </p:txBody>
+      </p:sp>
+      <p:sp>
+        <p:nvSpPr>
+          <p:cNvPr id="5" name="Notes Placeholder 4"/>
+          <p:cNvSpPr>
+            <a:spLocks noGrp="1"/>
+          </p:cNvSpPr>
+          <p:nvPr>
+            <p:ph type="body" sz="quarter" idx="3"/>
+          </p:nvPr>
+        </p:nvSpPr>
+        <p:spPr>
+          <a:xfrm>
+            <a:off x="685800" y="4343400"/>
+            <a:ext cx="5486400" cy="4114800"/>
+          </a:xfrm>
+          <a:prstGeom prst="rect">
+            <a:avLst/>
+          </a:prstGeom>
+        </p:spPr>
+        <p:txBody>
+          <a:bodyPr vert="horz" lIns="91440" tIns="45720" rIns="91440" bIns="45720" rtlCol="0"/>
+          <a:lstStyle/>
+          <a:p>
+            <a:pPr lvl="0"/>
+            <a:r>
+              <a:rPr lang="en-US" smtClean="0"/>
+              <a:t>Click to edit Master text styles</a:t>
+            </a:r>
+          </a:p>
+          <a:p>
+            <a:pPr lvl="1"/>
+            <a:r>
+              <a:rPr lang="en-US" smtClean="0"/>
+              <a:t>Second level</a:t>
+            </a:r>
+          </a:p>
+          <a:p>
+            <a:pPr lvl="2"/>
+            <a:r>
+              <a:rPr lang="en-US" smtClean="0"/>
+              <a:t>Third level</a:t>
+            </a:r>
+          </a:p>
+          <a:p>
+            <a:pPr lvl="3"/>
+            <a:r>
+              <a:rPr lang="en-US" smtClean="0"/>
+              <a:t>Fourth level</a:t>
+            </a:r>
+          </a:p>
+          <a:p>
+            <a:pPr lvl="4"/>
+            <a:r>
+              <a:rPr lang="en-US" smtClean="0"/>
+              <a:t>Fifth level</a:t>
+            </a:r>
+            <a:endParaRPr lang="en-US"/>
+          </a:p>
+        </p:txBody>
+      </p:sp>
+      <p:sp>
+        <p:nvSpPr>
+          <p:cNvPr id="6" name="Footer Placeholder 5"/>
+          <p:cNvSpPr>
+            <a:spLocks noGrp="1"/>
+          </p:cNvSpPr>
+          <p:nvPr>
+            <p:ph type="ftr" sz="quarter" idx="4"/>
+          </p:nvPr>
+        </p:nvSpPr>
+        <p:spPr>
+          <a:xfrm>
+            <a:off x="0" y="8685213"/>
+            <a:ext cx="2971800" cy="457200"/>
+          </a:xfrm>
+          <a:prstGeom prst="rect">
+            <a:avLst/>
+          </a:prstGeom>
+        </p:spPr>
+        <p:txBody>
+          <a:bodyPr vert="horz" lIns="91440" tIns="45720" rIns="91440" bIns="45720" rtlCol="0" anchor="b"/>
+          <a:lstStyle>
+            <a:lvl1pPr algn="l">
+              <a:defRPr sz="1200"/>
+            </a:lvl1pPr>
+          </a:lstStyle>
+          <a:p>
+            <a:endParaRPr lang="en-US"/>
+          </a:p>
+        </p:txBody>
+      </p:sp>
+      <p:sp>
+        <p:nvSpPr>
+          <p:cNvPr id="7" name="Slide Number Placeholder 6"/>
+          <p:cNvSpPr>
+            <a:spLocks noGrp="1"/>
+          </p:cNvSpPr>
+          <p:nvPr>
+            <p:ph type="sldNum" sz="quarter" idx="5"/>
+          </p:nvPr>
+        </p:nvSpPr>
+        <p:spPr>
+          <a:xfrm>
+            <a:off x="3884613" y="8685213"/>
+            <a:ext cx="2971800" cy="457200"/>
+          </a:xfrm>
+          <a:prstGeom prst="rect">
+            <a:avLst/>
+          </a:prstGeom>
+        </p:spPr>
+        <p:txBody>
+          <a:bodyPr vert="horz" lIns="91440" tIns="45720" rIns="91440" bIns="45720" rtlCol="0" anchor="b"/>
+          <a:lstStyle>
+            <a:lvl1pPr algn="r">
+              <a:defRPr sz="1200"/>
+            </a:lvl1pPr>
+          </a:lstStyle>
+          <a:p>
+            <a:fld id="{BB5E49A5-4136-284D-997B-48E1D791AD67}" type="slidenum">
+              <a:rPr lang="en-US" smtClean="0"/>
+              <a:t>‹#›</a:t>
+            </a:fld>
+            <a:endParaRPr lang="en-US"/>
+          </a:p>
+        </p:txBody>
+      </p:sp>
+    </p:spTree>
+    <p:extLst>
+      <p:ext uri="{BB962C8B-B14F-4D97-AF65-F5344CB8AC3E}">
+        <p14:creationId xmlns:p14="http://schemas.microsoft.com/office/powerpoint/2010/main" val="2623252185"/>
+      </p:ext>
+    </p:extLst>
+  </p:cSld>
+  <p:clrMap bg1="lt1" tx1="dk1" bg2="lt2" tx2="dk2" accent1="accent1" accent2="accent2" accent3="accent3" accent4="accent4" accent5="accent5" accent6="accent6" hlink="hlink" folHlink="folHlink"/>
+  <p:notesStyle>
+    <a:lvl1pPr marL="0" algn="l" defTabSz="457200" rtl="0" eaLnBrk="1" latinLnBrk="0" hangingPunct="1">
+      <a:defRPr sz="1200" kern="1200">
+        <a:solidFill>
+          <a:schemeClr val="tx1"/>
+        </a:solidFill>
+        <a:latin typeface="+mn-lt"/>
+        <a:ea typeface="+mn-ea"/>
+        <a:cs typeface="+mn-cs"/>
+      </a:defRPr>
+    </a:lvl1pPr>
+    <a:lvl2pPr marL="457200" algn="l" defTabSz="457200" rtl="0" eaLnBrk="1" latinLnBrk="0" hangingPunct="1">
+      <a:defRPr sz="1200" kern="1200">
+        <a:solidFill>
+          <a:schemeClr val="tx1"/>
+        </a:solidFill>
+        <a:latin typeface="+mn-lt"/>
+        <a:ea typeface="+mn-ea"/>
+        <a:cs typeface="+mn-cs"/>
+      </a:defRPr>
+    </a:lvl2pPr>
+    <a:lvl3pPr marL="914400" algn="l" defTabSz="457200" rtl="0" eaLnBrk="1" latinLnBrk="0" hangingPunct="1">
+      <a:defRPr sz="1200" kern="1200">
+        <a:solidFill>
+          <a:schemeClr val="tx1"/>
+        </a:solidFill>
+        <a:latin typeface="+mn-lt"/>
+        <a:ea typeface="+mn-ea"/>
+        <a:cs typeface="+mn-cs"/>
+      </a:defRPr>
+    </a:lvl3pPr>
+    <a:lvl4pPr marL="1371600" algn="l" defTabSz="457200" rtl="0" eaLnBrk="1" latinLnBrk="0" hangingPunct="1">
+      <a:defRPr sz="1200" kern="1200">
+        <a:solidFill>
+          <a:schemeClr val="tx1"/>
+        </a:solidFill>
+        <a:latin typeface="+mn-lt"/>
+        <a:ea typeface="+mn-ea"/>
+        <a:cs typeface="+mn-cs"/>
+      </a:defRPr>
+    </a:lvl4pPr>
+    <a:lvl5pPr marL="1828800" algn="l" defTabSz="457200" rtl="0" eaLnBrk="1" latinLnBrk="0" hangingPunct="1">
+      <a:defRPr sz="1200" kern="1200">
+        <a:solidFill>
+          <a:schemeClr val="tx1"/>
+        </a:solidFill>
+        <a:latin typeface="+mn-lt"/>
+        <a:ea typeface="+mn-ea"/>
+        <a:cs typeface="+mn-cs"/>
+      </a:defRPr>
+    </a:lvl5pPr>
+    <a:lvl6pPr marL="2286000" algn="l" defTabSz="457200" rtl="0" eaLnBrk="1" latinLnBrk="0" hangingPunct="1">
+      <a:defRPr sz="1200" kern="1200">
+        <a:solidFill>
+          <a:schemeClr val="tx1"/>
+        </a:solidFill>
+        <a:latin typeface="+mn-lt"/>
+        <a:ea typeface="+mn-ea"/>
+        <a:cs typeface="+mn-cs"/>
+      </a:defRPr>
+    </a:lvl6pPr>
+    <a:lvl7pPr marL="2743200" algn="l" defTabSz="457200" rtl="0" eaLnBrk="1" latinLnBrk="0" hangingPunct="1">
+      <a:defRPr sz="1200" kern="1200">
+        <a:solidFill>
+          <a:schemeClr val="tx1"/>
+        </a:solidFill>
+        <a:latin typeface="+mn-lt"/>
+        <a:ea typeface="+mn-ea"/>
+        <a:cs typeface="+mn-cs"/>
+      </a:defRPr>
+    </a:lvl7pPr>
+    <a:lvl8pPr marL="3200400" algn="l" defTabSz="457200" rtl="0" eaLnBrk="1" latinLnBrk="0" hangingPunct="1">
+      <a:defRPr sz="1200" kern="1200">
+        <a:solidFill>
+          <a:schemeClr val="tx1"/>
+        </a:solidFill>
+        <a:latin typeface="+mn-lt"/>
+        <a:ea typeface="+mn-ea"/>
+        <a:cs typeface="+mn-cs"/>
+      </a:defRPr>
+    </a:lvl8pPr>
+    <a:lvl9pPr marL="3657600" algn="l" defTabSz="457200" rtl="0" eaLnBrk="1" latinLnBrk="0" hangingPunct="1">
+      <a:defRPr sz="1200" kern="1200">
+        <a:solidFill>
+          <a:schemeClr val="tx1"/>
+        </a:solidFill>
+        <a:latin typeface="+mn-lt"/>
+        <a:ea typeface="+mn-ea"/>
+        <a:cs typeface="+mn-cs"/>
+      </a:defRPr>
+    </a:lvl9pPr>
+  </p:notesStyle>
+</p:notesMaster>
+</file>
+
+<file path=ppt/notesSlides/notesSlide1.xml><?xml version="1.0" encoding="utf-8"?>
+<p:notes xmlns:a="http://schemas.openxmlformats.org/drawingml/2006/main" xmlns:p="http://schemas.openxmlformats.org/presentationml/2006/main" xmlns:r="http://schemas.openxmlformats.org/officeDocument/2006/relationships">
+  <p:cSld>
+    <p:spTree>
+      <p:nvGrpSpPr>
+        <p:cNvPr id="1" name=""/>
+        <p:cNvGrpSpPr/>
+        <p:nvPr/>
+      </p:nvGrpSpPr>
+      <p:grpSpPr>
+        <a:xfrm>
+          <a:off x="0" y="0"/>
+          <a:ext cx="0" cy="0"/>
+          <a:chOff x="0" y="0"/>
+          <a:chExt cx="0" cy="0"/>
+        </a:xfrm>
+      </p:grpSpPr>
+      <p:sp>
+        <p:nvSpPr>
+          <p:cNvPr id="2" name="Slide Image Placeholder 1"/>
+          <p:cNvSpPr>
+            <a:spLocks noGrp="1"/>
+          </p:cNvSpPr>
+          <p:nvPr>
+            <p:ph type="sldImg" idx="2"/>
+          </p:nvPr>
+        </p:nvSpPr>
+        <p:spPr/>
+      </p:sp>
+      <p:sp>
+        <p:nvSpPr>
+          <p:cNvPr id="3" name="Notes Placeholder 2"/>
+          <p:cNvSpPr>
+            <a:spLocks noGrp="1"/>
+          </p:cNvSpPr>
+          <p:nvPr>
+            <p:ph type="body" idx="3" sz="quarter"/>
+          </p:nvPr>
+        </p:nvSpPr>
+        <p:spPr/>
+        <p:txBody>
+          <a:bodyPr/>
+          <a:lstStyle/>
+          <a:p>
+            <a:r>
+              <a:t>Two ways to show the demo:</a:t>
+            </a:r>
+          </a:p>
+          <a:p>
+            <a:r>
+              <a:t>• OPTION 1 (left): the embedded video plays in-slide on click — no internet or add-ins. Safe default.</a:t>
+            </a:r>
+          </a:p>
+          <a:p>
+            <a:r>
+              <a:t>• OPTION 2 (right): a live, interactive view. After the site is published to the main branch, insert the Microsoft ‘Web Viewer’ add-in (Insert &gt; Get Add-ins &gt; search ‘Web Viewer’ &gt; Add), paste https://nsai4insurance.com/pc-demo-widget.html, and resize it to fill the box. You can then click ‘Run Both Models’ inside the slide.</a:t>
+            </a:r>
+          </a:p>
+          <a:p>
+            <a:r>
+              <a:t>The ‘Open the live demo in a browser’ button works regardless — it just opens the page in your browser.</a:t>
+            </a:r>
+          </a:p>
+          <a:p>
+            <a:r>
+              <a:t>Before publishing, you can test the live view now via htmlpreview.github.io pointed at the branch copy of pc-demo-widget.html.</a:t>
+            </a:r>
+          </a:p>
+          <a:p>
+            <a:r>
+              <a:t>Once you decide, delete whichever option you don’t want.</a:t>
+            </a:r>
+          </a:p>
+        </p:txBody>
+      </p:sp>
+      <p:sp>
+        <p:nvSpPr>
+          <p:cNvPr id="4" name="Slide Number Placeholder 3"/>
+          <p:cNvSpPr>
+            <a:spLocks noGrp="1"/>
+          </p:cNvSpPr>
+          <p:nvPr>
+            <p:ph type="sldNum" idx="5" sz="quarter"/>
+          </p:nvPr>
+        </p:nvSpPr>
+        <p:spPr/>
+      </p:sp>
+    </p:spTree>
+  </p:cSld>
+  <p:clrMapOvr>
+    <a:masterClrMapping/>
+  </p:clrMapOvr>
+</p:notes>
 </file>
 
 <file path=ppt/slideLayouts/slideLayout1.xml><?xml version="1.0" encoding="utf-8"?>
@@ -7513,8 +7958,8 @@
         </p:nvSpPr>
         <p:spPr>
           <a:xfrm>
-            <a:off x="822960" y="384048"/>
-            <a:ext cx="10515600" cy="274320"/>
+            <a:off x="640080" y="365760"/>
+            <a:ext cx="10972800" cy="274320"/>
           </a:xfrm>
           <a:prstGeom prst="rect">
             <a:avLst/>
@@ -7522,12 +7967,22 @@
           <a:noFill/>
         </p:spPr>
         <p:txBody>
-          <a:bodyPr wrap="square" lIns="0" rIns="0" tIns="0" bIns="0">
+          <a:bodyPr wrap="square" anchor="t" lIns="25400" rIns="25400" tIns="25400" bIns="25400">
             <a:spAutoFit/>
           </a:bodyPr>
           <a:lstStyle/>
           <a:p>
-            <a:pPr algn="l"/>
+            <a:pPr algn="l">
+              <a:lnSpc>
+                <a:spcPct val="105000"/>
+              </a:lnSpc>
+              <a:spcBef>
+                <a:spcPts val="0"/>
+              </a:spcBef>
+              <a:spcAft>
+                <a:spcPts val="500"/>
+              </a:spcAft>
+            </a:pPr>
             <a:r>
               <a:rPr sz="1100" b="1" i="0">
                 <a:solidFill>
@@ -7535,7 +7990,7 @@
                 </a:solidFill>
                 <a:latin typeface="Calibri"/>
               </a:rPr>
-              <a:t>THE LIVE WALKTHROUGH  ·  EMBEDDED VIDEO — CLICK TO PLAY IN-SLIDE</a:t>
+              <a:t>THE LIVE DEMO  ·  TWO WAYS TO PRESENT IT — PICK ONE ONCE THE SITE IS PUBLISHED</a:t>
             </a:r>
           </a:p>
         </p:txBody>
@@ -7548,8 +8003,8 @@
         </p:nvSpPr>
         <p:spPr>
           <a:xfrm>
-            <a:off x="822960" y="713232"/>
-            <a:ext cx="10515600" cy="548640"/>
+            <a:off x="640080" y="676656"/>
+            <a:ext cx="10972800" cy="502920"/>
           </a:xfrm>
           <a:prstGeom prst="rect">
             <a:avLst/>
@@ -7557,12 +8012,22 @@
           <a:noFill/>
         </p:spPr>
         <p:txBody>
-          <a:bodyPr wrap="square" lIns="0" rIns="0" tIns="0" bIns="0">
+          <a:bodyPr wrap="square" anchor="t" lIns="25400" rIns="25400" tIns="25400" bIns="25400">
             <a:spAutoFit/>
           </a:bodyPr>
           <a:lstStyle/>
           <a:p>
-            <a:pPr algn="l"/>
+            <a:pPr algn="l">
+              <a:lnSpc>
+                <a:spcPct val="105000"/>
+              </a:lnSpc>
+              <a:spcBef>
+                <a:spcPts val="0"/>
+              </a:spcBef>
+              <a:spcAft>
+                <a:spcPts val="500"/>
+              </a:spcAft>
+            </a:pPr>
             <a:r>
               <a:rPr sz="2400" b="0" i="0">
                 <a:solidFill>
@@ -7570,14 +8035,68 @@
                 </a:solidFill>
                 <a:latin typeface="Georgia"/>
               </a:rPr>
-              <a:t>Watch both models run on the same submission.</a:t>
+              <a:t>Embedded video, or a live interactive view.</a:t>
+            </a:r>
+          </a:p>
+        </p:txBody>
+      </p:sp>
+      <p:sp>
+        <p:nvSpPr>
+          <p:cNvPr id="4" name="TextBox 3"/>
+          <p:cNvSpPr txBox="1"/>
+          <p:nvPr/>
+        </p:nvSpPr>
+        <p:spPr>
+          <a:xfrm>
+            <a:off x="640080" y="1417320"/>
+            <a:ext cx="5486400" cy="292608"/>
+          </a:xfrm>
+          <a:prstGeom prst="rect">
+            <a:avLst/>
+          </a:prstGeom>
+          <a:noFill/>
+        </p:spPr>
+        <p:txBody>
+          <a:bodyPr wrap="square" anchor="t" lIns="25400" rIns="25400" tIns="25400" bIns="25400">
+            <a:spAutoFit/>
+          </a:bodyPr>
+          <a:lstStyle/>
+          <a:p>
+            <a:pPr algn="l">
+              <a:lnSpc>
+                <a:spcPct val="105000"/>
+              </a:lnSpc>
+              <a:spcBef>
+                <a:spcPts val="0"/>
+              </a:spcBef>
+              <a:spcAft>
+                <a:spcPts val="500"/>
+              </a:spcAft>
+            </a:pPr>
+            <a:r>
+              <a:rPr sz="1200" b="1" i="0">
+                <a:solidFill>
+                  <a:srgbClr val="3F5E4A"/>
+                </a:solidFill>
+                <a:latin typeface="Calibri"/>
+              </a:rPr>
+              <a:t>OPTION 1 · EMBEDDED VIDEO</a:t>
+            </a:r>
+            <a:r>
+              <a:rPr sz="1100" b="0" i="1">
+                <a:solidFill>
+                  <a:srgbClr val="C9C2B5"/>
+                </a:solidFill>
+                <a:latin typeface="Calibri"/>
+              </a:rPr>
+              <a:t>   plays in-slide on click · works offline</a:t>
             </a:r>
           </a:p>
         </p:txBody>
       </p:sp>
       <p:pic>
         <p:nvPicPr>
-          <p:cNvPr id="4" name="NSAI-demo-run.mp4">
+          <p:cNvPr id="5" name="NSAI-demo-run.mp4">
             <a:hlinkClick r:id="" action="ppaction://media"/>
           </p:cNvPr>
           <p:cNvPicPr>
@@ -7600,8 +8119,8 @@
         </p:blipFill>
         <p:spPr>
           <a:xfrm>
-            <a:off x="1475721" y="1371600"/>
-            <a:ext cx="9240252" cy="5212080"/>
+            <a:off x="640080" y="1801368"/>
+            <a:ext cx="5486400" cy="3094672"/>
           </a:xfrm>
           <a:prstGeom prst="rect">
             <a:avLst/>
@@ -7610,14 +8129,14 @@
       </p:pic>
       <p:sp>
         <p:nvSpPr>
-          <p:cNvPr id="5" name="TextBox 4"/>
+          <p:cNvPr id="6" name="TextBox 5"/>
           <p:cNvSpPr txBox="1"/>
           <p:nvPr/>
         </p:nvSpPr>
         <p:spPr>
           <a:xfrm>
-            <a:off x="822960" y="6510528"/>
-            <a:ext cx="10515600" cy="274320"/>
+            <a:off x="640080" y="4969192"/>
+            <a:ext cx="5486400" cy="548640"/>
           </a:xfrm>
           <a:prstGeom prst="rect">
             <a:avLst/>
@@ -7625,20 +8144,397 @@
           <a:noFill/>
         </p:spPr>
         <p:txBody>
-          <a:bodyPr wrap="square" lIns="0" rIns="0" tIns="0" bIns="0">
+          <a:bodyPr wrap="square" anchor="t" lIns="25400" rIns="25400" tIns="25400" bIns="25400">
             <a:spAutoFit/>
           </a:bodyPr>
           <a:lstStyle/>
           <a:p>
-            <a:pPr algn="l"/>
-            <a:r>
-              <a:rPr sz="1000" b="0" i="1">
+            <a:pPr algn="l">
+              <a:lnSpc>
+                <a:spcPct val="110000"/>
+              </a:lnSpc>
+              <a:spcBef>
+                <a:spcPts val="0"/>
+              </a:spcBef>
+              <a:spcAft>
+                <a:spcPts val="500"/>
+              </a:spcAft>
+            </a:pPr>
+            <a:r>
+              <a:rPr sz="1100" b="0" i="0">
+                <a:solidFill>
+                  <a:srgbClr val="C9C2B5"/>
+                </a:solidFill>
+                <a:latin typeface="Calibri"/>
+              </a:rPr>
+              <a:t>No internet or add-ins needed. The 13-second run is baked into this file — good for any room.</a:t>
+            </a:r>
+          </a:p>
+        </p:txBody>
+      </p:sp>
+      <p:sp>
+        <p:nvSpPr>
+          <p:cNvPr id="7" name="TextBox 6"/>
+          <p:cNvSpPr txBox="1"/>
+          <p:nvPr/>
+        </p:nvSpPr>
+        <p:spPr>
+          <a:xfrm>
+            <a:off x="6400800" y="1417320"/>
+            <a:ext cx="5120640" cy="292608"/>
+          </a:xfrm>
+          <a:prstGeom prst="rect">
+            <a:avLst/>
+          </a:prstGeom>
+          <a:noFill/>
+        </p:spPr>
+        <p:txBody>
+          <a:bodyPr wrap="square" anchor="t" lIns="25400" rIns="25400" tIns="25400" bIns="25400">
+            <a:spAutoFit/>
+          </a:bodyPr>
+          <a:lstStyle/>
+          <a:p>
+            <a:pPr algn="l">
+              <a:lnSpc>
+                <a:spcPct val="105000"/>
+              </a:lnSpc>
+              <a:spcBef>
+                <a:spcPts val="0"/>
+              </a:spcBef>
+              <a:spcAft>
+                <a:spcPts val="500"/>
+              </a:spcAft>
+            </a:pPr>
+            <a:r>
+              <a:rPr sz="1200" b="1" i="0">
+                <a:solidFill>
+                  <a:srgbClr val="B8442E"/>
+                </a:solidFill>
+                <a:latin typeface="Calibri"/>
+              </a:rPr>
+              <a:t>OPTION 2 · LIVE WEB VIEWER</a:t>
+            </a:r>
+            <a:r>
+              <a:rPr sz="1100" b="0" i="1">
+                <a:solidFill>
+                  <a:srgbClr val="C9C2B5"/>
+                </a:solidFill>
+                <a:latin typeface="Calibri"/>
+              </a:rPr>
+              <a:t>   fully interactive · needs internet</a:t>
+            </a:r>
+          </a:p>
+        </p:txBody>
+      </p:sp>
+      <p:sp>
+        <p:nvSpPr>
+          <p:cNvPr id="8" name="Rectangle 7"/>
+          <p:cNvSpPr/>
+          <p:nvPr/>
+        </p:nvSpPr>
+        <p:spPr>
+          <a:xfrm>
+            <a:off x="6400800" y="1801368"/>
+            <a:ext cx="5120640" cy="3094672"/>
+          </a:xfrm>
+          <a:prstGeom prst="rect">
+            <a:avLst/>
+          </a:prstGeom>
+          <a:solidFill>
+            <a:srgbClr val="1A2027"/>
+          </a:solidFill>
+          <a:ln w="15875">
+            <a:solidFill>
+              <a:srgbClr val="C8A951"/>
+            </a:solidFill>
+          </a:ln>
+          <a:effectLst/>
+        </p:spPr>
+        <p:style>
+          <a:lnRef idx="1">
+            <a:schemeClr val="accent1"/>
+          </a:lnRef>
+          <a:fillRef idx="3">
+            <a:schemeClr val="accent1"/>
+          </a:fillRef>
+          <a:effectRef idx="2">
+            <a:schemeClr val="accent1"/>
+          </a:effectRef>
+          <a:fontRef idx="minor">
+            <a:schemeClr val="lt1"/>
+          </a:fontRef>
+        </p:style>
+        <p:txBody>
+          <a:bodyPr rtlCol="0" anchor="ctr"/>
+          <a:lstStyle/>
+          <a:p>
+            <a:pPr algn="ctr"/>
+          </a:p>
+        </p:txBody>
+      </p:sp>
+      <p:sp>
+        <p:nvSpPr>
+          <p:cNvPr id="9" name="TextBox 8"/>
+          <p:cNvSpPr txBox="1"/>
+          <p:nvPr/>
+        </p:nvSpPr>
+        <p:spPr>
+          <a:xfrm>
+            <a:off x="6675120" y="2057400"/>
+            <a:ext cx="4572000" cy="2637472"/>
+          </a:xfrm>
+          <a:prstGeom prst="rect">
+            <a:avLst/>
+          </a:prstGeom>
+          <a:noFill/>
+        </p:spPr>
+        <p:txBody>
+          <a:bodyPr wrap="square" anchor="t" lIns="25400" rIns="25400" tIns="25400" bIns="25400">
+            <a:spAutoFit/>
+          </a:bodyPr>
+          <a:lstStyle/>
+          <a:p>
+            <a:pPr algn="l">
+              <a:lnSpc>
+                <a:spcPct val="110000"/>
+              </a:lnSpc>
+              <a:spcBef>
+                <a:spcPts val="0"/>
+              </a:spcBef>
+              <a:spcAft>
+                <a:spcPts val="800"/>
+              </a:spcAft>
+            </a:pPr>
+            <a:r>
+              <a:rPr sz="1200" b="1" i="0">
+                <a:solidFill>
+                  <a:srgbClr val="C8A951"/>
+                </a:solidFill>
+                <a:latin typeface="Calibri"/>
+              </a:rPr>
+              <a:t>WEB VIEWER GOES HERE</a:t>
+            </a:r>
+          </a:p>
+          <a:p>
+            <a:pPr algn="l">
+              <a:lnSpc>
+                <a:spcPct val="110000"/>
+              </a:lnSpc>
+              <a:spcBef>
+                <a:spcPts val="0"/>
+              </a:spcBef>
+              <a:spcAft>
+                <a:spcPts val="800"/>
+              </a:spcAft>
+            </a:pPr>
+            <a:r>
+              <a:rPr sz="1300" b="0" i="0">
+                <a:solidFill>
+                  <a:srgbClr val="F4EFE6"/>
+                </a:solidFill>
+                <a:latin typeface="Calibri"/>
+              </a:rPr>
+              <a:t>Insert it once, in PowerPoint:</a:t>
+            </a:r>
+          </a:p>
+          <a:p>
+            <a:pPr algn="l">
+              <a:lnSpc>
+                <a:spcPct val="110000"/>
+              </a:lnSpc>
+              <a:spcBef>
+                <a:spcPts val="0"/>
+              </a:spcBef>
+              <a:spcAft>
+                <a:spcPts val="800"/>
+              </a:spcAft>
+            </a:pPr>
+            <a:r>
+              <a:rPr sz="1200" b="0" i="0">
+                <a:solidFill>
+                  <a:srgbClr val="C9C2B5"/>
+                </a:solidFill>
+                <a:latin typeface="Calibri"/>
+              </a:rPr>
+              <a:t>1.  Insert ▸ Get Add-ins  →  search “Web Viewer”  →  Add</a:t>
+            </a:r>
+          </a:p>
+          <a:p>
+            <a:pPr algn="l">
+              <a:lnSpc>
+                <a:spcPct val="110000"/>
+              </a:lnSpc>
+              <a:spcBef>
+                <a:spcPts val="0"/>
+              </a:spcBef>
+              <a:spcAft>
+                <a:spcPts val="800"/>
+              </a:spcAft>
+            </a:pPr>
+            <a:r>
+              <a:rPr sz="1200" b="0" i="0">
+                <a:solidFill>
+                  <a:srgbClr val="C9C2B5"/>
+                </a:solidFill>
+                <a:latin typeface="Calibri"/>
+              </a:rPr>
+              <a:t>2.  Paste this URL into the add-in:</a:t>
+            </a:r>
+          </a:p>
+          <a:p>
+            <a:pPr algn="l">
+              <a:lnSpc>
+                <a:spcPct val="110000"/>
+              </a:lnSpc>
+              <a:spcBef>
+                <a:spcPts val="0"/>
+              </a:spcBef>
+              <a:spcAft>
+                <a:spcPts val="800"/>
+              </a:spcAft>
+            </a:pPr>
+            <a:r>
+              <a:rPr sz="1200" b="1" i="0">
+                <a:solidFill>
+                  <a:srgbClr val="C8A951"/>
+                </a:solidFill>
+                <a:latin typeface="Calibri"/>
+              </a:rPr>
+              <a:t>https://nsai4insurance.com/pc-demo-widget.html</a:t>
+            </a:r>
+          </a:p>
+          <a:p>
+            <a:pPr algn="l">
+              <a:lnSpc>
+                <a:spcPct val="110000"/>
+              </a:lnSpc>
+              <a:spcBef>
+                <a:spcPts val="0"/>
+              </a:spcBef>
+              <a:spcAft>
+                <a:spcPts val="800"/>
+              </a:spcAft>
+            </a:pPr>
+            <a:r>
+              <a:rPr sz="1200" b="0" i="0">
+                <a:solidFill>
+                  <a:srgbClr val="C9C2B5"/>
+                </a:solidFill>
+                <a:latin typeface="Calibri"/>
+              </a:rPr>
+              <a:t>3.  Resize the add-in to fill this box.</a:t>
+            </a:r>
+          </a:p>
+          <a:p>
+            <a:pPr algn="l">
+              <a:lnSpc>
+                <a:spcPct val="110000"/>
+              </a:lnSpc>
+              <a:spcBef>
+                <a:spcPts val="0"/>
+              </a:spcBef>
+              <a:spcAft>
+                <a:spcPts val="800"/>
+              </a:spcAft>
+            </a:pPr>
+            <a:r>
+              <a:rPr sz="1050" b="0" i="1">
                 <a:solidFill>
                   <a:srgbClr val="6B6458"/>
                 </a:solidFill>
                 <a:latin typeface="Calibri"/>
               </a:rPr>
-              <a:t>Plays inside the slide on click (no internet needed). 13-second run · loops back to the start when finished.</a:t>
+              <a:t>Live after the site is published to the main branch.</a:t>
+            </a:r>
+          </a:p>
+        </p:txBody>
+      </p:sp>
+      <p:sp>
+        <p:nvSpPr>
+          <p:cNvPr id="10" name="Rectangle 9"/>
+          <p:cNvSpPr/>
+          <p:nvPr/>
+        </p:nvSpPr>
+        <p:spPr>
+          <a:xfrm>
+            <a:off x="6400800" y="5005768"/>
+            <a:ext cx="5120640" cy="457200"/>
+          </a:xfrm>
+          <a:prstGeom prst="rect">
+            <a:avLst/>
+          </a:prstGeom>
+          <a:solidFill>
+            <a:srgbClr val="B8442E"/>
+          </a:solidFill>
+          <a:ln>
+            <a:noFill/>
+          </a:ln>
+          <a:effectLst/>
+        </p:spPr>
+        <p:style>
+          <a:lnRef idx="1">
+            <a:schemeClr val="accent1"/>
+          </a:lnRef>
+          <a:fillRef idx="3">
+            <a:schemeClr val="accent1"/>
+          </a:fillRef>
+          <a:effectRef idx="2">
+            <a:schemeClr val="accent1"/>
+          </a:effectRef>
+          <a:fontRef idx="minor">
+            <a:schemeClr val="lt1"/>
+          </a:fontRef>
+        </p:style>
+        <p:txBody>
+          <a:bodyPr rtlCol="0" anchor="ctr"/>
+          <a:lstStyle/>
+          <a:p>
+            <a:pPr algn="ctr"/>
+          </a:p>
+        </p:txBody>
+      </p:sp>
+      <p:sp>
+        <p:nvSpPr>
+          <p:cNvPr id="11" name="TextBox 10"/>
+          <p:cNvSpPr txBox="1"/>
+          <p:nvPr/>
+        </p:nvSpPr>
+        <p:spPr>
+          <a:xfrm>
+            <a:off x="6400800" y="5005768"/>
+            <a:ext cx="5120640" cy="457200"/>
+          </a:xfrm>
+          <a:prstGeom prst="rect">
+            <a:avLst/>
+          </a:prstGeom>
+          <a:noFill/>
+        </p:spPr>
+        <p:txBody>
+          <a:bodyPr wrap="square" anchor="ctr" lIns="25400" rIns="25400" tIns="25400" bIns="25400">
+            <a:spAutoFit/>
+          </a:bodyPr>
+          <a:lstStyle/>
+          <a:p>
+            <a:pPr algn="ctr">
+              <a:lnSpc>
+                <a:spcPct val="105000"/>
+              </a:lnSpc>
+              <a:spcBef>
+                <a:spcPts val="0"/>
+              </a:spcBef>
+              <a:spcAft>
+                <a:spcPts val="0"/>
+              </a:spcAft>
+            </a:pPr>
+            <a:r>
+              <a:rPr sz="1300" b="1" i="0">
+                <a:solidFill>
+                  <a:srgbClr val="F4EFE6"/>
+                </a:solidFill>
+                <a:latin typeface="Calibri"/>
+                <a:hlinkClick r:id="rId5"/>
+              </a:rPr>
+              <a:t>▶  Open the live demo in a browser</a:t>
             </a:r>
           </a:p>
         </p:txBody>
@@ -7661,7 +8557,7 @@
                   </p:stCondLst>
                 </p:cTn>
                 <p:tgtEl>
-                  <p:spTgt spid="4"/>
+                  <p:spTgt spid="5"/>
                 </p:tgtEl>
               </p:cMediaNode>
             </p:video>
@@ -7991,4 +8887,324 @@
   </a:objectDefaults>
   <a:extraClrSchemeLst/>
 </a:theme>
+</file>
+
+<file path=ppt/theme/theme2.xml><?xml version="1.0" encoding="utf-8"?>
+<a:theme xmlns:a="http://schemas.openxmlformats.org/drawingml/2006/main" name="Office Theme">
+  <a:themeElements>
+    <a:clrScheme name="Office">
+      <a:dk1>
+        <a:sysClr val="windowText" lastClr="000000"/>
+      </a:dk1>
+      <a:lt1>
+        <a:sysClr val="window" lastClr="FFFFFF"/>
+      </a:lt1>
+      <a:dk2>
+        <a:srgbClr val="1F497D"/>
+      </a:dk2>
+      <a:lt2>
+        <a:srgbClr val="EEECE1"/>
+      </a:lt2>
+      <a:accent1>
+        <a:srgbClr val="4F81BD"/>
+      </a:accent1>
+      <a:accent2>
+        <a:srgbClr val="C0504D"/>
+      </a:accent2>
+      <a:accent3>
+        <a:srgbClr val="9BBB59"/>
+      </a:accent3>
+      <a:accent4>
+        <a:srgbClr val="8064A2"/>
+      </a:accent4>
+      <a:accent5>
+        <a:srgbClr val="4BACC6"/>
+      </a:accent5>
+      <a:accent6>
+        <a:srgbClr val="F79646"/>
+      </a:accent6>
+      <a:hlink>
+        <a:srgbClr val="0000FF"/>
+      </a:hlink>
+      <a:folHlink>
+        <a:srgbClr val="800080"/>
+      </a:folHlink>
+    </a:clrScheme>
+    <a:fontScheme name="Office">
+      <a:majorFont>
+        <a:latin typeface="Calibri"/>
+        <a:ea typeface=""/>
+        <a:cs typeface=""/>
+        <a:font script="Jpan" typeface="ＭＳ Ｐゴシック"/>
+        <a:font script="Hang" typeface="맑은 고딕"/>
+        <a:font script="Hans" typeface="宋体"/>
+        <a:font script="Hant" typeface="新細明體"/>
+        <a:font script="Arab" typeface="Times New Roman"/>
+        <a:font script="Hebr" typeface="Times New Roman"/>
+        <a:font script="Thai" typeface="Angsana New"/>
+        <a:font script="Ethi" typeface="Nyala"/>
+        <a:font script="Beng" typeface="Vrinda"/>
+        <a:font script="Gujr" typeface="Shruti"/>
+        <a:font script="Khmr" typeface="MoolBoran"/>
+        <a:font script="Knda" typeface="Tunga"/>
+        <a:font script="Guru" typeface="Raavi"/>
+        <a:font script="Cans" typeface="Euphemia"/>
+        <a:font script="Cher" typeface="Plantagenet Cherokee"/>
+        <a:font script="Yiii" typeface="Microsoft Yi Baiti"/>
+        <a:font script="Tibt" typeface="Microsoft Himalaya"/>
+        <a:font script="Thaa" typeface="MV Boli"/>
+        <a:font script="Deva" typeface="Mangal"/>
+        <a:font script="Telu" typeface="Gautami"/>
+        <a:font script="Taml" typeface="Latha"/>
+        <a:font script="Syrc" typeface="Estrangelo Edessa"/>
+        <a:font script="Orya" typeface="Kalinga"/>
+        <a:font script="Mlym" typeface="Kartika"/>
+        <a:font script="Laoo" typeface="DokChampa"/>
+        <a:font script="Sinh" typeface="Iskoola Pota"/>
+        <a:font script="Mong" typeface="Mongolian Baiti"/>
+        <a:font script="Viet" typeface="Times New Roman"/>
+        <a:font script="Uigh" typeface="Microsoft Uighur"/>
+        <a:font script="Geor" typeface="Sylfaen"/>
+      </a:majorFont>
+      <a:minorFont>
+        <a:latin typeface="Calibri"/>
+        <a:ea typeface=""/>
+        <a:cs typeface=""/>
+        <a:font script="Jpan" typeface="ＭＳ Ｐゴシック"/>
+        <a:font script="Hang" typeface="맑은 고딕"/>
+        <a:font script="Hans" typeface="宋体"/>
+        <a:font script="Hant" typeface="新細明體"/>
+        <a:font script="Arab" typeface="Arial"/>
+        <a:font script="Hebr" typeface="Arial"/>
+        <a:font script="Thai" typeface="Cordia New"/>
+        <a:font script="Ethi" typeface="Nyala"/>
+        <a:font script="Beng" typeface="Vrinda"/>
+        <a:font script="Gujr" typeface="Shruti"/>
+        <a:font script="Khmr" typeface="DaunPenh"/>
+        <a:font script="Knda" typeface="Tunga"/>
+        <a:font script="Guru" typeface="Raavi"/>
+        <a:font script="Cans" typeface="Euphemia"/>
+        <a:font script="Cher" typeface="Plantagenet Cherokee"/>
+        <a:font script="Yiii" typeface="Microsoft Yi Baiti"/>
+        <a:font script="Tibt" typeface="Microsoft Himalaya"/>
+        <a:font script="Thaa" typeface="MV Boli"/>
+        <a:font script="Deva" typeface="Mangal"/>
+        <a:font script="Telu" typeface="Gautami"/>
+        <a:font script="Taml" typeface="Latha"/>
+        <a:font script="Syrc" typeface="Estrangelo Edessa"/>
+        <a:font script="Orya" typeface="Kalinga"/>
+        <a:font script="Mlym" typeface="Kartika"/>
+        <a:font script="Laoo" typeface="DokChampa"/>
+        <a:font script="Sinh" typeface="Iskoola Pota"/>
+        <a:font script="Mong" typeface="Mongolian Baiti"/>
+        <a:font script="Viet" typeface="Arial"/>
+        <a:font script="Uigh" typeface="Microsoft Uighur"/>
+        <a:font script="Geor" typeface="Sylfaen"/>
+      </a:minorFont>
+    </a:fontScheme>
+    <a:fmtScheme name="Office">
+      <a:fillStyleLst>
+        <a:solidFill>
+          <a:schemeClr val="phClr"/>
+        </a:solidFill>
+        <a:gradFill rotWithShape="1">
+          <a:gsLst>
+            <a:gs pos="0">
+              <a:schemeClr val="phClr">
+                <a:tint val="50000"/>
+                <a:satMod val="300000"/>
+              </a:schemeClr>
+            </a:gs>
+            <a:gs pos="35000">
+              <a:schemeClr val="phClr">
+                <a:tint val="37000"/>
+                <a:satMod val="300000"/>
+              </a:schemeClr>
+            </a:gs>
+            <a:gs pos="100000">
+              <a:schemeClr val="phClr">
+                <a:tint val="15000"/>
+                <a:satMod val="350000"/>
+              </a:schemeClr>
+            </a:gs>
+          </a:gsLst>
+          <a:lin ang="16200000" scaled="1"/>
+        </a:gradFill>
+        <a:gradFill rotWithShape="1">
+          <a:gsLst>
+            <a:gs pos="0">
+              <a:schemeClr val="phClr">
+                <a:tint val="100000"/>
+                <a:shade val="100000"/>
+                <a:satMod val="130000"/>
+              </a:schemeClr>
+            </a:gs>
+            <a:gs pos="100000">
+              <a:schemeClr val="phClr">
+                <a:tint val="50000"/>
+                <a:shade val="100000"/>
+                <a:satMod val="350000"/>
+              </a:schemeClr>
+            </a:gs>
+          </a:gsLst>
+          <a:lin ang="16200000" scaled="0"/>
+        </a:gradFill>
+      </a:fillStyleLst>
+      <a:lnStyleLst>
+        <a:ln w="9525" cap="flat" cmpd="sng" algn="ctr">
+          <a:solidFill>
+            <a:schemeClr val="phClr">
+              <a:shade val="95000"/>
+              <a:satMod val="105000"/>
+            </a:schemeClr>
+          </a:solidFill>
+          <a:prstDash val="solid"/>
+        </a:ln>
+        <a:ln w="25400" cap="flat" cmpd="sng" algn="ctr">
+          <a:solidFill>
+            <a:schemeClr val="phClr"/>
+          </a:solidFill>
+          <a:prstDash val="solid"/>
+        </a:ln>
+        <a:ln w="38100" cap="flat" cmpd="sng" algn="ctr">
+          <a:solidFill>
+            <a:schemeClr val="phClr"/>
+          </a:solidFill>
+          <a:prstDash val="solid"/>
+        </a:ln>
+      </a:lnStyleLst>
+      <a:effectStyleLst>
+        <a:effectStyle>
+          <a:effectLst>
+            <a:outerShdw blurRad="40000" dist="20000" dir="5400000" rotWithShape="0">
+              <a:srgbClr val="000000">
+                <a:alpha val="38000"/>
+              </a:srgbClr>
+            </a:outerShdw>
+          </a:effectLst>
+        </a:effectStyle>
+        <a:effectStyle>
+          <a:effectLst>
+            <a:outerShdw blurRad="40000" dist="23000" dir="5400000" rotWithShape="0">
+              <a:srgbClr val="000000">
+                <a:alpha val="35000"/>
+              </a:srgbClr>
+            </a:outerShdw>
+          </a:effectLst>
+        </a:effectStyle>
+        <a:effectStyle>
+          <a:effectLst>
+            <a:outerShdw blurRad="40000" dist="23000" dir="5400000" rotWithShape="0">
+              <a:srgbClr val="000000">
+                <a:alpha val="35000"/>
+              </a:srgbClr>
+            </a:outerShdw>
+          </a:effectLst>
+          <a:scene3d>
+            <a:camera prst="orthographicFront">
+              <a:rot lat="0" lon="0" rev="0"/>
+            </a:camera>
+            <a:lightRig rig="threePt" dir="t">
+              <a:rot lat="0" lon="0" rev="1200000"/>
+            </a:lightRig>
+          </a:scene3d>
+          <a:sp3d>
+            <a:bevelT w="63500" h="25400"/>
+          </a:sp3d>
+        </a:effectStyle>
+      </a:effectStyleLst>
+      <a:bgFillStyleLst>
+        <a:solidFill>
+          <a:schemeClr val="phClr"/>
+        </a:solidFill>
+        <a:gradFill rotWithShape="1">
+          <a:gsLst>
+            <a:gs pos="0">
+              <a:schemeClr val="phClr">
+                <a:tint val="40000"/>
+                <a:satMod val="350000"/>
+              </a:schemeClr>
+            </a:gs>
+            <a:gs pos="40000">
+              <a:schemeClr val="phClr">
+                <a:tint val="45000"/>
+                <a:shade val="99000"/>
+                <a:satMod val="350000"/>
+              </a:schemeClr>
+            </a:gs>
+            <a:gs pos="100000">
+              <a:schemeClr val="phClr">
+                <a:shade val="20000"/>
+                <a:satMod val="255000"/>
+              </a:schemeClr>
+            </a:gs>
+          </a:gsLst>
+          <a:path path="circle">
+            <a:fillToRect l="50000" t="-80000" r="50000" b="180000"/>
+          </a:path>
+        </a:gradFill>
+        <a:gradFill rotWithShape="1">
+          <a:gsLst>
+            <a:gs pos="0">
+              <a:schemeClr val="phClr">
+                <a:tint val="80000"/>
+                <a:satMod val="300000"/>
+              </a:schemeClr>
+            </a:gs>
+            <a:gs pos="100000">
+              <a:schemeClr val="phClr">
+                <a:shade val="30000"/>
+                <a:satMod val="200000"/>
+              </a:schemeClr>
+            </a:gs>
+          </a:gsLst>
+          <a:path path="circle">
+            <a:fillToRect l="50000" t="50000" r="50000" b="50000"/>
+          </a:path>
+        </a:gradFill>
+      </a:bgFillStyleLst>
+    </a:fmtScheme>
+  </a:themeElements>
+  <a:objectDefaults>
+    <a:spDef>
+      <a:spPr/>
+      <a:bodyPr/>
+      <a:lstStyle/>
+      <a:style>
+        <a:lnRef idx="1">
+          <a:schemeClr val="accent1"/>
+        </a:lnRef>
+        <a:fillRef idx="3">
+          <a:schemeClr val="accent1"/>
+        </a:fillRef>
+        <a:effectRef idx="2">
+          <a:schemeClr val="accent1"/>
+        </a:effectRef>
+        <a:fontRef idx="minor">
+          <a:schemeClr val="lt1"/>
+        </a:fontRef>
+      </a:style>
+    </a:spDef>
+    <a:lnDef>
+      <a:spPr/>
+      <a:bodyPr/>
+      <a:lstStyle/>
+      <a:style>
+        <a:lnRef idx="2">
+          <a:schemeClr val="accent1"/>
+        </a:lnRef>
+        <a:fillRef idx="0">
+          <a:schemeClr val="accent1"/>
+        </a:fillRef>
+        <a:effectRef idx="1">
+          <a:schemeClr val="accent1"/>
+        </a:effectRef>
+        <a:fontRef idx="minor">
+          <a:schemeClr val="tx1"/>
+        </a:fontRef>
+      </a:style>
+    </a:lnDef>
+  </a:objectDefaults>
+  <a:extraClrSchemeLst/>
+</a:theme>
 </file>
</xml_diff>

<commit_message>
Fix appendix to show all eight retrieved passages
The retrieval appendix claimed 8 passages but listed only 4 condensed
lines. List all eight, grouped as Pass 1 (appetite guide, 5) and
Pass 2 (rate manual + coverage defaults, 3), so the header matches
the content.

https://claude.ai/code/session_01Njv3bBvPktKkkSQNzyxEeu
</commit_message>
<xml_diff>
--- a/NSAI-Small-Commercial-Exec-Summary.pptx
+++ b/NSAI-Small-Commercial-Exec-Summary.pptx
@@ -8596,7 +8596,7 @@
         </p:nvSpPr>
         <p:spPr>
           <a:xfrm>
-            <a:off x="640080" y="411480"/>
+            <a:off x="640080" y="384048"/>
             <a:ext cx="10972800" cy="274320"/>
           </a:xfrm>
           <a:prstGeom prst="rect">
@@ -8641,8 +8641,8 @@
         </p:nvSpPr>
         <p:spPr>
           <a:xfrm>
-            <a:off x="640080" y="731520"/>
-            <a:ext cx="10972800" cy="548640"/>
+            <a:off x="640080" y="694944"/>
+            <a:ext cx="10972800" cy="502920"/>
           </a:xfrm>
           <a:prstGeom prst="rect">
             <a:avLst/>
@@ -8667,7 +8667,7 @@
               </a:spcAft>
             </a:pPr>
             <a:r>
-              <a:rPr sz="2600" b="0" i="0">
+              <a:rPr sz="2500" b="0" i="0">
                 <a:solidFill>
                   <a:srgbClr val="0F1419"/>
                 </a:solidFill>
@@ -8686,8 +8686,8 @@
         </p:nvSpPr>
         <p:spPr>
           <a:xfrm>
-            <a:off x="640080" y="1554480"/>
-            <a:ext cx="5394960" cy="420624"/>
+            <a:off x="640080" y="1444752"/>
+            <a:ext cx="5806440" cy="402336"/>
           </a:xfrm>
           <a:prstGeom prst="rect">
             <a:avLst/>
@@ -8730,8 +8730,8 @@
         </p:nvSpPr>
         <p:spPr>
           <a:xfrm>
-            <a:off x="804672" y="1572768"/>
-            <a:ext cx="5120640" cy="384048"/>
+            <a:off x="804672" y="1463040"/>
+            <a:ext cx="5532120" cy="365760"/>
           </a:xfrm>
           <a:prstGeom prst="rect">
             <a:avLst/>
@@ -8775,8 +8775,8 @@
         </p:nvSpPr>
         <p:spPr>
           <a:xfrm>
-            <a:off x="640080" y="1975104"/>
-            <a:ext cx="5394960" cy="3236976"/>
+            <a:off x="640080" y="1847088"/>
+            <a:ext cx="5806440" cy="3575303"/>
           </a:xfrm>
           <a:prstGeom prst="rect">
             <a:avLst/>
@@ -8821,8 +8821,8 @@
         </p:nvSpPr>
         <p:spPr>
           <a:xfrm>
-            <a:off x="841248" y="2139696"/>
-            <a:ext cx="4992624" cy="2926080"/>
+            <a:off x="841248" y="1956816"/>
+            <a:ext cx="5404104" cy="3374135"/>
           </a:xfrm>
           <a:prstGeom prst="rect">
             <a:avLst/>
@@ -8837,150 +8837,318 @@
           <a:p>
             <a:pPr algn="l">
               <a:lnSpc>
-                <a:spcPct val="108000"/>
-              </a:lnSpc>
-              <a:spcBef>
-                <a:spcPts val="0"/>
-              </a:spcBef>
-              <a:spcAft>
-                <a:spcPts val="900"/>
-              </a:spcAft>
-            </a:pPr>
-            <a:r>
-              <a:rPr sz="1100" b="1" i="0">
+                <a:spcPct val="100000"/>
+              </a:lnSpc>
+              <a:spcBef>
+                <a:spcPts val="0"/>
+              </a:spcBef>
+              <a:spcAft>
+                <a:spcPts val="350"/>
+              </a:spcAft>
+            </a:pPr>
+            <a:r>
+              <a:rPr sz="950" b="1" i="0">
                 <a:solidFill>
                   <a:srgbClr val="3F5E4A"/>
                 </a:solidFill>
+                <a:latin typeface="Calibri"/>
+              </a:rPr>
+              <a:t>PASS 1 · APPETITE GUIDE (5)</a:t>
+            </a:r>
+          </a:p>
+          <a:p>
+            <a:pPr algn="l">
+              <a:lnSpc>
+                <a:spcPct val="100000"/>
+              </a:lnSpc>
+              <a:spcBef>
+                <a:spcPts val="0"/>
+              </a:spcBef>
+              <a:spcAft>
+                <a:spcPts val="350"/>
+              </a:spcAft>
+            </a:pPr>
+            <a:r>
+              <a:rPr sz="1050" b="1" i="0">
+                <a:solidFill>
+                  <a:srgbClr val="3F5E4A"/>
+                </a:solidFill>
                 <a:latin typeface="Consolas"/>
               </a:rPr>
-              <a:t>[Appetite-Guide §2.4]  </a:t>
-            </a:r>
-            <a:r>
-              <a:rPr sz="1200" b="0" i="0">
+              <a:t>§2.4  </a:t>
+            </a:r>
+            <a:r>
+              <a:rPr sz="1050" b="0" i="0">
                 <a:solidFill>
                   <a:srgbClr val="2A3340"/>
                 </a:solidFill>
                 <a:latin typeface="Calibri"/>
               </a:rPr>
-              <a:t>Owner-operated handyman, revenue &lt; $250K → in appetite, auto-bind. Class HANDYMAN_LIGHT_INTERIOR.</a:t>
-            </a:r>
-          </a:p>
-          <a:p>
-            <a:pPr algn="l">
-              <a:lnSpc>
-                <a:spcPct val="108000"/>
-              </a:lnSpc>
-              <a:spcBef>
-                <a:spcPts val="0"/>
-              </a:spcBef>
-              <a:spcAft>
-                <a:spcPts val="900"/>
-              </a:spcAft>
-            </a:pPr>
-            <a:r>
-              <a:rPr sz="1100" b="1" i="0">
+              <a:t>handyman, rev &lt; $250K → in appetite, auto-bind</a:t>
+            </a:r>
+          </a:p>
+          <a:p>
+            <a:pPr algn="l">
+              <a:lnSpc>
+                <a:spcPct val="100000"/>
+              </a:lnSpc>
+              <a:spcBef>
+                <a:spcPts val="0"/>
+              </a:spcBef>
+              <a:spcAft>
+                <a:spcPts val="350"/>
+              </a:spcAft>
+            </a:pPr>
+            <a:r>
+              <a:rPr sz="1050" b="1" i="0">
                 <a:solidFill>
                   <a:srgbClr val="3F5E4A"/>
                 </a:solidFill>
                 <a:latin typeface="Consolas"/>
               </a:rPr>
-              <a:t>[Appetite-Guide §2.4.1]  </a:t>
-            </a:r>
-            <a:r>
-              <a:rPr sz="1200" b="0" i="0">
+              <a:t>§2.4.1  </a:t>
+            </a:r>
+            <a:r>
+              <a:rPr sz="1050" b="0" i="0">
                 <a:solidFill>
                   <a:srgbClr val="2A3340"/>
                 </a:solidFill>
                 <a:latin typeface="Calibri"/>
               </a:rPr>
-              <a:t>Eligible: drywall, fixtures, minor bath/kitchen, interior paint.</a:t>
-            </a:r>
-          </a:p>
-          <a:p>
-            <a:pPr algn="l">
-              <a:lnSpc>
-                <a:spcPct val="108000"/>
-              </a:lnSpc>
-              <a:spcBef>
-                <a:spcPts val="0"/>
-              </a:spcBef>
-              <a:spcAft>
-                <a:spcPts val="900"/>
-              </a:spcAft>
-            </a:pPr>
-            <a:r>
-              <a:rPr sz="1100" b="1" i="0">
+              <a:t>eligible: drywall, fixtures, bath/kitchen, interior paint</a:t>
+            </a:r>
+          </a:p>
+          <a:p>
+            <a:pPr algn="l">
+              <a:lnSpc>
+                <a:spcPct val="100000"/>
+              </a:lnSpc>
+              <a:spcBef>
+                <a:spcPts val="0"/>
+              </a:spcBef>
+              <a:spcAft>
+                <a:spcPts val="350"/>
+              </a:spcAft>
+            </a:pPr>
+            <a:r>
+              <a:rPr sz="1050" b="1" i="0">
                 <a:solidFill>
                   <a:srgbClr val="3F5E4A"/>
                 </a:solidFill>
                 <a:latin typeface="Consolas"/>
               </a:rPr>
-              <a:t>[Rate-Manual §AZ-4 / 4.3]  </a:t>
-            </a:r>
-            <a:r>
-              <a:rPr sz="1200" b="0" i="0">
+              <a:t>§1.2  </a:t>
+            </a:r>
+            <a:r>
+              <a:rPr sz="1050" b="0" i="0">
                 <a:solidFill>
                   <a:srgbClr val="2A3340"/>
                 </a:solidFill>
                 <a:latin typeface="Calibri"/>
               </a:rPr>
-              <a:t>Rate band B2, streamlined BOP; typical bound premium $1,700–$2,000.</a:t>
-            </a:r>
-          </a:p>
-          <a:p>
-            <a:pPr algn="l">
-              <a:lnSpc>
-                <a:spcPct val="108000"/>
-              </a:lnSpc>
-              <a:spcBef>
-                <a:spcPts val="0"/>
-              </a:spcBef>
-              <a:spcAft>
-                <a:spcPts val="900"/>
-              </a:spcAft>
-            </a:pPr>
-            <a:r>
-              <a:rPr sz="1100" b="1" i="0">
+              <a:t>Arizona: admitted, streamlined, no surcharge</a:t>
+            </a:r>
+          </a:p>
+          <a:p>
+            <a:pPr algn="l">
+              <a:lnSpc>
+                <a:spcPct val="100000"/>
+              </a:lnSpc>
+              <a:spcBef>
+                <a:spcPts val="0"/>
+              </a:spcBef>
+              <a:spcAft>
+                <a:spcPts val="350"/>
+              </a:spcAft>
+            </a:pPr>
+            <a:r>
+              <a:rPr sz="1050" b="1" i="0">
                 <a:solidFill>
                   <a:srgbClr val="3F5E4A"/>
                 </a:solidFill>
                 <a:latin typeface="Consolas"/>
               </a:rPr>
-              <a:t>[Coverage-Defaults §DTC-1]  </a:t>
-            </a:r>
-            <a:r>
-              <a:rPr sz="1200" b="0" i="0">
+              <a:t>§3.1  </a:t>
+            </a:r>
+            <a:r>
+              <a:rPr sz="1050" b="0" i="0">
                 <a:solidFill>
                   <a:srgbClr val="2A3340"/>
                 </a:solidFill>
                 <a:latin typeface="Calibri"/>
               </a:rPr>
-              <a:t>Standard package: $1M/$2M GL, $10K tools, $25K AOP.</a:t>
-            </a:r>
-          </a:p>
-          <a:p>
-            <a:pPr algn="l">
-              <a:lnSpc>
-                <a:spcPct val="108000"/>
-              </a:lnSpc>
-              <a:spcBef>
-                <a:spcPts val="0"/>
-              </a:spcBef>
-              <a:spcAft>
-                <a:spcPts val="900"/>
-              </a:spcAft>
-            </a:pPr>
-            <a:r>
-              <a:rPr sz="1200" b="1" i="0">
+              <a:t>sole prop / owner + ≤3 helpers eligible</a:t>
+            </a:r>
+          </a:p>
+          <a:p>
+            <a:pPr algn="l">
+              <a:lnSpc>
+                <a:spcPct val="100000"/>
+              </a:lnSpc>
+              <a:spcBef>
+                <a:spcPts val="0"/>
+              </a:spcBef>
+              <a:spcAft>
+                <a:spcPts val="350"/>
+              </a:spcAft>
+            </a:pPr>
+            <a:r>
+              <a:rPr sz="1050" b="1" i="0">
+                <a:solidFill>
+                  <a:srgbClr val="3F5E4A"/>
+                </a:solidFill>
+                <a:latin typeface="Consolas"/>
+              </a:rPr>
+              <a:t>§2.0  </a:t>
+            </a:r>
+            <a:r>
+              <a:rPr sz="1050" b="0" i="0">
+                <a:solidFill>
+                  <a:srgbClr val="2A3340"/>
+                </a:solidFill>
+                <a:latin typeface="Calibri"/>
+              </a:rPr>
+              <a:t>DTC: in-appetite classes get an instant bindable quote</a:t>
+            </a:r>
+          </a:p>
+          <a:p>
+            <a:pPr algn="l">
+              <a:lnSpc>
+                <a:spcPct val="100000"/>
+              </a:lnSpc>
+              <a:spcBef>
+                <a:spcPts val="0"/>
+              </a:spcBef>
+              <a:spcAft>
+                <a:spcPts val="350"/>
+              </a:spcAft>
+            </a:pPr>
+            <a:r>
+              <a:rPr sz="950" b="1" i="0">
+                <a:solidFill>
+                  <a:srgbClr val="3F5E4A"/>
+                </a:solidFill>
+                <a:latin typeface="Calibri"/>
+              </a:rPr>
+              <a:t>PASS 2 · RATE MANUAL + COVERAGE DEFAULTS (3)</a:t>
+            </a:r>
+          </a:p>
+          <a:p>
+            <a:pPr algn="l">
+              <a:lnSpc>
+                <a:spcPct val="100000"/>
+              </a:lnSpc>
+              <a:spcBef>
+                <a:spcPts val="0"/>
+              </a:spcBef>
+              <a:spcAft>
+                <a:spcPts val="350"/>
+              </a:spcAft>
+            </a:pPr>
+            <a:r>
+              <a:rPr sz="1050" b="1" i="0">
+                <a:solidFill>
+                  <a:srgbClr val="3F5E4A"/>
+                </a:solidFill>
+                <a:latin typeface="Consolas"/>
+              </a:rPr>
+              <a:t>§AZ-4  </a:t>
+            </a:r>
+            <a:r>
+              <a:rPr sz="1050" b="0" i="0">
+                <a:solidFill>
+                  <a:srgbClr val="2A3340"/>
+                </a:solidFill>
+                <a:latin typeface="Calibri"/>
+              </a:rPr>
+              <a:t>rate band B2, streamlined BOP</a:t>
+            </a:r>
+          </a:p>
+          <a:p>
+            <a:pPr algn="l">
+              <a:lnSpc>
+                <a:spcPct val="100000"/>
+              </a:lnSpc>
+              <a:spcBef>
+                <a:spcPts val="0"/>
+              </a:spcBef>
+              <a:spcAft>
+                <a:spcPts val="350"/>
+              </a:spcAft>
+            </a:pPr>
+            <a:r>
+              <a:rPr sz="1050" b="1" i="0">
+                <a:solidFill>
+                  <a:srgbClr val="3F5E4A"/>
+                </a:solidFill>
+                <a:latin typeface="Consolas"/>
+              </a:rPr>
+              <a:t>§AZ-4.3  </a:t>
+            </a:r>
+            <a:r>
+              <a:rPr sz="1050" b="0" i="0">
+                <a:solidFill>
+                  <a:srgbClr val="2A3340"/>
+                </a:solidFill>
+                <a:latin typeface="Calibri"/>
+              </a:rPr>
+              <a:t>typical bound premium $1,700–$2,000</a:t>
+            </a:r>
+          </a:p>
+          <a:p>
+            <a:pPr algn="l">
+              <a:lnSpc>
+                <a:spcPct val="100000"/>
+              </a:lnSpc>
+              <a:spcBef>
+                <a:spcPts val="0"/>
+              </a:spcBef>
+              <a:spcAft>
+                <a:spcPts val="350"/>
+              </a:spcAft>
+            </a:pPr>
+            <a:r>
+              <a:rPr sz="1050" b="1" i="0">
+                <a:solidFill>
+                  <a:srgbClr val="3F5E4A"/>
+                </a:solidFill>
+                <a:latin typeface="Consolas"/>
+              </a:rPr>
+              <a:t>§DTC-1  </a:t>
+            </a:r>
+            <a:r>
+              <a:rPr sz="1050" b="0" i="0">
+                <a:solidFill>
+                  <a:srgbClr val="2A3340"/>
+                </a:solidFill>
+                <a:latin typeface="Calibri"/>
+              </a:rPr>
+              <a:t>defaults: $1M/$2M GL, $10K tools, $25K AOP</a:t>
+            </a:r>
+          </a:p>
+          <a:p>
+            <a:pPr algn="l">
+              <a:lnSpc>
+                <a:spcPct val="100000"/>
+              </a:lnSpc>
+              <a:spcBef>
+                <a:spcPts val="0"/>
+              </a:spcBef>
+              <a:spcAft>
+                <a:spcPts val="350"/>
+              </a:spcAft>
+            </a:pPr>
+            <a:r>
+              <a:rPr sz="1050" b="1" i="0">
                 <a:solidFill>
                   <a:srgbClr val="0F1419"/>
                 </a:solidFill>
                 <a:latin typeface="Calibri"/>
               </a:rPr>
-              <a:t>→ All eight reinforce the same answer: </a:t>
-            </a:r>
-            <a:r>
-              <a:rPr sz="1200" b="0" i="1">
+              <a:t>→ All eight reinforce one answer: </a:t>
+            </a:r>
+            <a:r>
+              <a:rPr sz="1050" b="0" i="1">
                 <a:solidFill>
                   <a:srgbClr val="0F1419"/>
                 </a:solidFill>
@@ -8999,8 +9167,8 @@
         </p:nvSpPr>
         <p:spPr>
           <a:xfrm>
-            <a:off x="6172200" y="1554480"/>
-            <a:ext cx="5349240" cy="420624"/>
+            <a:off x="6629400" y="1444752"/>
+            <a:ext cx="4892040" cy="402336"/>
           </a:xfrm>
           <a:prstGeom prst="rect">
             <a:avLst/>
@@ -9043,8 +9211,8 @@
         </p:nvSpPr>
         <p:spPr>
           <a:xfrm>
-            <a:off x="6336792" y="1572768"/>
-            <a:ext cx="5074920" cy="384048"/>
+            <a:off x="6793992" y="1463040"/>
+            <a:ext cx="4617720" cy="365760"/>
           </a:xfrm>
           <a:prstGeom prst="rect">
             <a:avLst/>
@@ -9088,8 +9256,8 @@
         </p:nvSpPr>
         <p:spPr>
           <a:xfrm>
-            <a:off x="6172200" y="1975104"/>
-            <a:ext cx="5349240" cy="3236976"/>
+            <a:off x="6629400" y="1847088"/>
+            <a:ext cx="4892040" cy="3575303"/>
           </a:xfrm>
           <a:prstGeom prst="rect">
             <a:avLst/>
@@ -9134,8 +9302,8 @@
         </p:nvSpPr>
         <p:spPr>
           <a:xfrm>
-            <a:off x="6373368" y="2139696"/>
-            <a:ext cx="4946904" cy="2926080"/>
+            <a:off x="6830568" y="1993392"/>
+            <a:ext cx="4489704" cy="3337559"/>
           </a:xfrm>
           <a:prstGeom prst="rect">
             <a:avLst/>
@@ -9150,13 +9318,13 @@
           <a:p>
             <a:pPr algn="l">
               <a:lnSpc>
-                <a:spcPct val="110000"/>
-              </a:lnSpc>
-              <a:spcBef>
-                <a:spcPts val="0"/>
-              </a:spcBef>
-              <a:spcAft>
-                <a:spcPts val="1100"/>
+                <a:spcPct val="112000"/>
+              </a:lnSpc>
+              <a:spcBef>
+                <a:spcPts val="0"/>
+              </a:spcBef>
+              <a:spcAft>
+                <a:spcPts val="800"/>
               </a:spcAft>
             </a:pPr>
             <a:r>
@@ -9166,10 +9334,10 @@
                 </a:solidFill>
                 <a:latin typeface="Consolas"/>
               </a:rPr>
-              <a:t>[Appetite-Guide §2.6]  </a:t>
-            </a:r>
-            <a:r>
-              <a:rPr sz="1200" b="0" i="0">
+              <a:t>§2.6  </a:t>
+            </a:r>
+            <a:r>
+              <a:rPr sz="1150" b="0" i="0">
                 <a:solidFill>
                   <a:srgbClr val="2A3340"/>
                 </a:solidFill>
@@ -9178,7 +9346,7 @@
               <a:t>Water-heater / plumbing → water-damage exposure to landlord property. In appetite </a:t>
             </a:r>
             <a:r>
-              <a:rPr sz="1200" b="1" i="0">
+              <a:rPr sz="1150" b="1" i="0">
                 <a:solidFill>
                   <a:srgbClr val="2A3340"/>
                 </a:solidFill>
@@ -9187,25 +9355,47 @@
               <a:t>only with water-damage terms / sublimit</a:t>
             </a:r>
             <a:r>
-              <a:rPr sz="1200" b="0" i="0">
+              <a:rPr sz="1150" b="0" i="0">
                 <a:solidFill>
                   <a:srgbClr val="2A3340"/>
                 </a:solidFill>
                 <a:latin typeface="Calibri"/>
               </a:rPr>
-              <a:t>. Class PLUMBING_WATER_HEATER.</a:t>
-            </a:r>
-          </a:p>
-          <a:p>
-            <a:pPr algn="l">
-              <a:lnSpc>
-                <a:spcPct val="110000"/>
-              </a:lnSpc>
-              <a:spcBef>
-                <a:spcPts val="0"/>
-              </a:spcBef>
-              <a:spcAft>
-                <a:spcPts val="1100"/>
+              <a:t>.</a:t>
+            </a:r>
+          </a:p>
+          <a:p>
+            <a:pPr algn="l">
+              <a:lnSpc>
+                <a:spcPct val="112000"/>
+              </a:lnSpc>
+              <a:spcBef>
+                <a:spcPts val="0"/>
+              </a:spcBef>
+              <a:spcAft>
+                <a:spcPts val="800"/>
+              </a:spcAft>
+            </a:pPr>
+            <a:r>
+              <a:rPr sz="600" b="0" i="0">
+                <a:solidFill>
+                  <a:srgbClr val="2A3340"/>
+                </a:solidFill>
+                <a:latin typeface="Calibri"/>
+              </a:rPr>
+              <a:t/>
+            </a:r>
+          </a:p>
+          <a:p>
+            <a:pPr algn="l">
+              <a:lnSpc>
+                <a:spcPct val="112000"/>
+              </a:lnSpc>
+              <a:spcBef>
+                <a:spcPts val="0"/>
+              </a:spcBef>
+              <a:spcAft>
+                <a:spcPts val="800"/>
               </a:spcAft>
             </a:pPr>
             <a:r>
@@ -9215,19 +9405,19 @@
                 </a:solidFill>
                 <a:latin typeface="Consolas"/>
               </a:rPr>
-              <a:t>[Appetite-Guide §2.7]  </a:t>
-            </a:r>
-            <a:r>
-              <a:rPr sz="1200" b="0" i="0">
+              <a:t>§2.7  </a:t>
+            </a:r>
+            <a:r>
+              <a:rPr sz="1150" b="0" i="0">
                 <a:solidFill>
                   <a:srgbClr val="2A3340"/>
                 </a:solidFill>
                 <a:latin typeface="Calibri"/>
               </a:rPr>
-              <a:t>Roof-surface work — leak patching, shingle repair/replacement, work from a roof — carries height/fall exposure and is </a:t>
-            </a:r>
-            <a:r>
-              <a:rPr sz="1200" b="1" i="0">
+              <a:t>Roof-surface work — leak patching, shingle repair, work from a roof — carries height/fall exposure and is </a:t>
+            </a:r>
+            <a:r>
+              <a:rPr sz="1150" b="1" i="0">
                 <a:solidFill>
                   <a:srgbClr val="2A3340"/>
                 </a:solidFill>
@@ -9236,35 +9426,57 @@
               <a:t>outside standard DTC handyman appetite</a:t>
             </a:r>
             <a:r>
-              <a:rPr sz="1200" b="0" i="0">
+              <a:rPr sz="1150" b="0" i="0">
                 <a:solidFill>
                   <a:srgbClr val="2A3340"/>
                 </a:solidFill>
                 <a:latin typeface="Calibri"/>
               </a:rPr>
-              <a:t> → specialty UW. Class ROOF_SURFACE_WORK.</a:t>
-            </a:r>
-          </a:p>
-          <a:p>
-            <a:pPr algn="l">
-              <a:lnSpc>
-                <a:spcPct val="110000"/>
-              </a:lnSpc>
-              <a:spcBef>
-                <a:spcPts val="0"/>
-              </a:spcBef>
-              <a:spcAft>
-                <a:spcPts val="1100"/>
-              </a:spcAft>
-            </a:pPr>
-            <a:r>
-              <a:rPr sz="1200" b="1" i="0">
+              <a:t> → specialty UW.</a:t>
+            </a:r>
+          </a:p>
+          <a:p>
+            <a:pPr algn="l">
+              <a:lnSpc>
+                <a:spcPct val="112000"/>
+              </a:lnSpc>
+              <a:spcBef>
+                <a:spcPts val="0"/>
+              </a:spcBef>
+              <a:spcAft>
+                <a:spcPts val="800"/>
+              </a:spcAft>
+            </a:pPr>
+            <a:r>
+              <a:rPr sz="600" b="0" i="0">
+                <a:solidFill>
+                  <a:srgbClr val="2A3340"/>
+                </a:solidFill>
+                <a:latin typeface="Calibri"/>
+              </a:rPr>
+              <a:t/>
+            </a:r>
+          </a:p>
+          <a:p>
+            <a:pPr algn="l">
+              <a:lnSpc>
+                <a:spcPct val="112000"/>
+              </a:lnSpc>
+              <a:spcBef>
+                <a:spcPts val="0"/>
+              </a:spcBef>
+              <a:spcAft>
+                <a:spcPts val="800"/>
+              </a:spcAft>
+            </a:pPr>
+            <a:r>
+              <a:rPr sz="1150" b="1" i="0">
                 <a:solidFill>
                   <a:srgbClr val="0F1419"/>
                 </a:solidFill>
                 <a:latin typeface="Calibri"/>
               </a:rPr>
-              <a:t>→ The query was “handyman,” so §2.4 ranked first and these never surfaced.</a:t>
+              <a:t>→ The query was “handyman,” so §2.4 ranked first; §2.6 and §2.7 never surfaced.</a:t>
             </a:r>
           </a:p>
         </p:txBody>
@@ -9277,8 +9489,8 @@
         </p:nvSpPr>
         <p:spPr>
           <a:xfrm>
-            <a:off x="640080" y="5394960"/>
-            <a:ext cx="10881360" cy="914400"/>
+            <a:off x="640080" y="5586983"/>
+            <a:ext cx="10881360" cy="841248"/>
           </a:xfrm>
           <a:prstGeom prst="rect">
             <a:avLst/>
@@ -9323,8 +9535,8 @@
         </p:nvSpPr>
         <p:spPr>
           <a:xfrm>
-            <a:off x="868680" y="5513832"/>
-            <a:ext cx="10424160" cy="713232"/>
+            <a:off x="868680" y="5696711"/>
+            <a:ext cx="10424160" cy="640080"/>
           </a:xfrm>
           <a:prstGeom prst="rect">
             <a:avLst/>
@@ -9339,7 +9551,7 @@
           <a:p>
             <a:pPr algn="l">
               <a:lnSpc>
-                <a:spcPct val="115000"/>
+                <a:spcPct val="112000"/>
               </a:lnSpc>
               <a:spcBef>
                 <a:spcPts val="0"/>
@@ -9358,7 +9570,7 @@
               <a:t>Where it goes wrong:  </a:t>
             </a:r>
             <a:r>
-              <a:rPr sz="1300" b="0" i="0">
+              <a:rPr sz="1250" b="0" i="0">
                 <a:solidFill>
                   <a:srgbClr val="2A3340"/>
                 </a:solidFill>
@@ -9367,7 +9579,7 @@
               <a:t>not a broken step — a missing one. Retrieval is steered by the bundled “handyman” query, and even if §2.6 / §2.7 were retrieved, generation isn’t bound to honor them. The neurosymbolic lane decomposes the customer’s words into the activities that </a:t>
             </a:r>
             <a:r>
-              <a:rPr sz="1300" b="0" i="1">
+              <a:rPr sz="1250" b="0" i="1">
                 <a:solidFill>
                   <a:srgbClr val="2A3340"/>
                 </a:solidFill>
@@ -9376,7 +9588,7 @@
               <a:t>trigger</a:t>
             </a:r>
             <a:r>
-              <a:rPr sz="1300" b="0" i="0">
+              <a:rPr sz="1250" b="0" i="0">
                 <a:solidFill>
                   <a:srgbClr val="2A3340"/>
                 </a:solidFill>

</xml_diff>

<commit_message>
Rework demo video: consistent top-down lanes + guided pauses
Rebuild the embedded demo video so both lanes read top-down (fixes the
mismatched anchoring) and turn it into a guided walkthrough: it plays
the run, then holds ~11s on four key moments with a presenter callout
and a highlight on the relevant element — the LLM miss, the NSAI
appetite breach catch, the shared underwriting+claims ontology, and the
two-option payoff. Refresh the embedded MP4 and poster accordingly.

https://claude.ai/code/session_01Njv3bBvPktKkkSQNzyxEeu
</commit_message>
<xml_diff>
--- a/NSAI-Small-Commercial-Exec-Summary.pptx
+++ b/NSAI-Small-Commercial-Exec-Summary.pptx
@@ -4900,7 +4900,7 @@
         <p:spPr>
           <a:xfrm>
             <a:off x="640080" y="1801368"/>
-            <a:ext cx="5486400" cy="3094672"/>
+            <a:ext cx="5486400" cy="3437572"/>
           </a:xfrm>
           <a:prstGeom prst="rect">
             <a:avLst/>
@@ -4915,7 +4915,7 @@
         </p:nvSpPr>
         <p:spPr>
           <a:xfrm>
-            <a:off x="640080" y="4969192"/>
+            <a:off x="640080" y="5312092"/>
             <a:ext cx="5486400" cy="548640"/>
           </a:xfrm>
           <a:prstGeom prst="rect">
@@ -5015,7 +5015,7 @@
         <p:spPr>
           <a:xfrm>
             <a:off x="6400800" y="1801368"/>
-            <a:ext cx="5120640" cy="3094672"/>
+            <a:ext cx="5120640" cy="3437572"/>
           </a:xfrm>
           <a:prstGeom prst="rect">
             <a:avLst/>
@@ -5061,7 +5061,7 @@
         <p:spPr>
           <a:xfrm>
             <a:off x="6675120" y="2057400"/>
-            <a:ext cx="4572000" cy="2637472"/>
+            <a:ext cx="4572000" cy="2980372"/>
           </a:xfrm>
           <a:prstGeom prst="rect">
             <a:avLst/>
@@ -5237,7 +5237,7 @@
         </p:nvSpPr>
         <p:spPr>
           <a:xfrm>
-            <a:off x="6400800" y="5005768"/>
+            <a:off x="6400800" y="5348668"/>
             <a:ext cx="5120640" cy="457200"/>
           </a:xfrm>
           <a:prstGeom prst="rect">
@@ -5281,7 +5281,7 @@
         </p:nvSpPr>
         <p:spPr>
           <a:xfrm>
-            <a:off x="6400800" y="5005768"/>
+            <a:off x="6400800" y="5348668"/>
             <a:ext cx="5120640" cy="457200"/>
           </a:xfrm>
           <a:prstGeom prst="rect">

</xml_diff>